<commit_message>
README.md updated. Need ongoing progress
</commit_message>
<xml_diff>
--- a/Mini_Project1_Aaron_Tan_Drugs.pptx
+++ b/Mini_Project1_Aaron_Tan_Drugs.pptx
@@ -426,7 +426,7 @@
           <a:p>
             <a:fld id="{E80C50CD-E178-4744-9B35-B2F624D6C5E9}" type="datetimeFigureOut">
               <a:rPr lang="en-US" smtClean="0"/>
-              <a:t>9/11/2025</a:t>
+              <a:t>10/24/2025</a:t>
             </a:fld>
             <a:endParaRPr lang="en-US"/>
           </a:p>
@@ -624,7 +624,7 @@
           <a:p>
             <a:fld id="{E80C50CD-E178-4744-9B35-B2F624D6C5E9}" type="datetimeFigureOut">
               <a:rPr lang="en-US" smtClean="0"/>
-              <a:t>9/11/2025</a:t>
+              <a:t>10/24/2025</a:t>
             </a:fld>
             <a:endParaRPr lang="en-US"/>
           </a:p>
@@ -832,7 +832,7 @@
           <a:p>
             <a:fld id="{E80C50CD-E178-4744-9B35-B2F624D6C5E9}" type="datetimeFigureOut">
               <a:rPr lang="en-US" smtClean="0"/>
-              <a:t>9/11/2025</a:t>
+              <a:t>10/24/2025</a:t>
             </a:fld>
             <a:endParaRPr lang="en-US"/>
           </a:p>
@@ -1082,7 +1082,7 @@
           <a:p>
             <a:fld id="{E80C50CD-E178-4744-9B35-B2F624D6C5E9}" type="datetimeFigureOut">
               <a:rPr lang="en-US" smtClean="0"/>
-              <a:t>9/11/2025</a:t>
+              <a:t>10/24/2025</a:t>
             </a:fld>
             <a:endParaRPr lang="en-US"/>
           </a:p>
@@ -1361,7 +1361,7 @@
           <a:p>
             <a:fld id="{E80C50CD-E178-4744-9B35-B2F624D6C5E9}" type="datetimeFigureOut">
               <a:rPr lang="en-US" smtClean="0"/>
-              <a:t>9/11/2025</a:t>
+              <a:t>10/24/2025</a:t>
             </a:fld>
             <a:endParaRPr lang="en-US"/>
           </a:p>
@@ -1678,7 +1678,7 @@
           <a:p>
             <a:fld id="{E80C50CD-E178-4744-9B35-B2F624D6C5E9}" type="datetimeFigureOut">
               <a:rPr lang="en-US" smtClean="0"/>
-              <a:t>9/11/2025</a:t>
+              <a:t>10/24/2025</a:t>
             </a:fld>
             <a:endParaRPr lang="en-US"/>
           </a:p>
@@ -2094,7 +2094,7 @@
           <a:p>
             <a:fld id="{E80C50CD-E178-4744-9B35-B2F624D6C5E9}" type="datetimeFigureOut">
               <a:rPr lang="en-US" smtClean="0"/>
-              <a:t>9/11/2025</a:t>
+              <a:t>10/24/2025</a:t>
             </a:fld>
             <a:endParaRPr lang="en-US"/>
           </a:p>
@@ -2235,7 +2235,7 @@
           <a:p>
             <a:fld id="{E80C50CD-E178-4744-9B35-B2F624D6C5E9}" type="datetimeFigureOut">
               <a:rPr lang="en-US" smtClean="0"/>
-              <a:t>9/11/2025</a:t>
+              <a:t>10/24/2025</a:t>
             </a:fld>
             <a:endParaRPr lang="en-US"/>
           </a:p>
@@ -2348,7 +2348,7 @@
           <a:p>
             <a:fld id="{E80C50CD-E178-4744-9B35-B2F624D6C5E9}" type="datetimeFigureOut">
               <a:rPr lang="en-US" smtClean="0"/>
-              <a:t>9/11/2025</a:t>
+              <a:t>10/24/2025</a:t>
             </a:fld>
             <a:endParaRPr lang="en-US"/>
           </a:p>
@@ -2665,7 +2665,7 @@
           <a:p>
             <a:fld id="{E80C50CD-E178-4744-9B35-B2F624D6C5E9}" type="datetimeFigureOut">
               <a:rPr lang="en-US" smtClean="0"/>
-              <a:t>9/11/2025</a:t>
+              <a:t>10/24/2025</a:t>
             </a:fld>
             <a:endParaRPr lang="en-US"/>
           </a:p>
@@ -2957,7 +2957,7 @@
           <a:p>
             <a:fld id="{E80C50CD-E178-4744-9B35-B2F624D6C5E9}" type="datetimeFigureOut">
               <a:rPr lang="en-US" smtClean="0"/>
-              <a:t>9/11/2025</a:t>
+              <a:t>10/24/2025</a:t>
             </a:fld>
             <a:endParaRPr lang="en-US"/>
           </a:p>
@@ -3197,7 +3197,7 @@
             <a:fld id="{E80C50CD-E178-4744-9B35-B2F624D6C5E9}" type="datetimeFigureOut">
               <a:rPr lang="en-US" smtClean="0"/>
               <a:pPr/>
-              <a:t>9/11/2025</a:t>
+              <a:t>10/24/2025</a:t>
             </a:fld>
             <a:endParaRPr lang="en-US"/>
           </a:p>
@@ -3804,7 +3804,7 @@
         </p:blipFill>
         <p:spPr>
           <a:xfrm>
-            <a:off x="-2" y="-4"/>
+            <a:off x="-2" y="27706"/>
             <a:ext cx="12192001" cy="6858001"/>
           </a:xfrm>
           <a:prstGeom prst="rect">

</xml_diff>